<commit_message>
Correct an overclaim in the deck
The verification line said the automated player completes the objective on
"every seed". That was asserted, not measured. It is 12 seeds, all passing, and
the slide now says so.
</commit_message>
<xml_diff>
--- a/docs/PARITY-final-review.pptx
+++ b/docs/PARITY-final-review.pptx
@@ -125,14 +125,14 @@
   <p:extLst>
     <p:ext uri="{521415D9-36F7-43E2-AB2F-B90AF26B5E84}">
       <p14:sectionLst xmlns:p14="http://schemas.microsoft.com/office/powerpoint/2010/main">
-        <p14:section name="The problem" id="{4a79a6b9-5048-85dc-0d25-90439016a0ae}">
+        <p14:section name="The problem" id="{88cd6086-39d3-86f1-a3db-c6e82eead584}">
           <p14:sldIdLst>
             <p14:sldId id="257"/>
             <p14:sldId id="258"/>
             <p14:sldId id="259"/>
           </p14:sldIdLst>
         </p14:section>
-        <p14:section name="How it works" id="{d90f4d63-a26e-29d3-1d51-6ad39bf08006}">
+        <p14:section name="How it works" id="{4c56b303-19f8-9e1f-263a-bc3e8de3f205}">
           <p14:sldIdLst>
             <p14:sldId id="260"/>
             <p14:sldId id="261"/>
@@ -140,7 +140,7 @@
             <p14:sldId id="263"/>
           </p14:sldIdLst>
         </p14:section>
-        <p14:section name="Results" id="{ecdcc773-3e78-c49a-e1b0-138ab8f141bf}">
+        <p14:section name="Results" id="{96eb1846-603f-e2e4-3238-2ad4297f2120}">
           <p14:sldIdLst>
             <p14:sldId id="264"/>
             <p14:sldId id="265"/>
@@ -150,7 +150,7 @@
             <p14:sldId id="269"/>
           </p14:sldIdLst>
         </p14:section>
-        <p14:section name="The build" id="{838b6a10-724d-58a7-244f-025be0d5bf45}">
+        <p14:section name="The build" id="{e4a33d5a-ea1a-5d34-6911-6539113e21a6}">
           <p14:sldIdLst>
             <p14:sldId id="270"/>
             <p14:sldId id="271"/>
@@ -6839,7 +6839,7 @@
                   <a:srgbClr val="7A7059"/>
                 </a:solidFill>
               </a:rPr>
-              <a:t> completes the objective on every seed   ·   </a:t>
+              <a:t> completes the objective on all 12 seeds tested   ·   </a:t>
             </a:r>
             <a:pPr indent="0" marL="0">
               <a:buNone/>

</xml_diff>

<commit_message>
Add a contribution slide and the panel's identifying details
Section 1.7 of the report says the project guidelines require the candidate to
distinguish what was added from what was already there, and Table 1.4 does it
component by component. The deck had no such split - both names on the title
slide and nothing to tell a panel who wrote which half. A new slide mirrors
Table 1.4.

The title slide now carries registration numbers, team, guide and panel, taken
from the allocation sheet. A panel marking twenty teams should not have to ask
who is presenting.
</commit_message>
<xml_diff>
--- a/docs/PARITY-final-review.pptx
+++ b/docs/PARITY-final-review.pptx
@@ -24,9 +24,10 @@
     <p:sldId id="272" r:id="rId18"/>
     <p:sldId id="273" r:id="rId19"/>
     <p:sldId id="274" r:id="rId20"/>
+    <p:sldId id="275" r:id="rId21"/>
   </p:sldIdLst>
   <p:notesMasterIdLst>
-    <p:notesMasterId r:id="rId21"/>
+    <p:notesMasterId r:id="rId22"/>
   </p:notesMasterIdLst>
   <p:sldSz cx="12192000" cy="6858000"/>
   <p:notesSz cx="6858000" cy="12192000"/>
@@ -125,14 +126,14 @@
   <p:extLst>
     <p:ext uri="{521415D9-36F7-43E2-AB2F-B90AF26B5E84}">
       <p14:sectionLst xmlns:p14="http://schemas.microsoft.com/office/powerpoint/2010/main">
-        <p14:section name="The problem" id="{88cd6086-39d3-86f1-a3db-c6e82eead584}">
+        <p14:section name="The problem" id="{15fa5742-ba9d-d31a-cd8e-a47cca37089a}">
           <p14:sldIdLst>
             <p14:sldId id="257"/>
             <p14:sldId id="258"/>
             <p14:sldId id="259"/>
           </p14:sldIdLst>
         </p14:section>
-        <p14:section name="How it works" id="{4c56b303-19f8-9e1f-263a-bc3e8de3f205}">
+        <p14:section name="How it works" id="{f456e4be-51e9-be30-c6ce-a44fac592dc5}">
           <p14:sldIdLst>
             <p14:sldId id="260"/>
             <p14:sldId id="261"/>
@@ -140,7 +141,7 @@
             <p14:sldId id="263"/>
           </p14:sldIdLst>
         </p14:section>
-        <p14:section name="Results" id="{96eb1846-603f-e2e4-3238-2ad4297f2120}">
+        <p14:section name="Results" id="{d09f2604-0d9b-09c1-1d66-580956584bab}">
           <p14:sldIdLst>
             <p14:sldId id="264"/>
             <p14:sldId id="265"/>
@@ -150,13 +151,14 @@
             <p14:sldId id="269"/>
           </p14:sldIdLst>
         </p14:section>
-        <p14:section name="The build" id="{e4a33d5a-ea1a-5d34-6911-6539113e21a6}">
+        <p14:section name="The build" id="{1f06df63-3dae-de0b-25f0-839aa7e4e5e8}">
           <p14:sldIdLst>
             <p14:sldId id="270"/>
             <p14:sldId id="271"/>
             <p14:sldId id="272"/>
             <p14:sldId id="273"/>
             <p14:sldId id="274"/>
+            <p14:sldId id="275"/>
           </p14:sldIdLst>
         </p14:section>
       </p14:sectionLst>
@@ -1355,7 +1357,7 @@
           <a:p>
             <a:r>
               <a:rPr lang="en-US" dirty="0"/>
-              <a:t>Say all four out loud. A panel that hears you name your own limits stops hunting for them.</a:t>
+              <a:t>Panels mark attribution. Name which half is yours in one sentence and move on — do not read the lists aloud.</a:t>
             </a:r>
             <a:endParaRPr lang="en-US" dirty="0"/>
           </a:p>
@@ -1443,7 +1445,7 @@
           <a:p>
             <a:r>
               <a:rPr lang="en-US" dirty="0"/>
-              <a:t>Close on the second-to-last line. The project set out to make a predictive AI the player can feel, and the measurement that it works is the deliverable.</a:t>
+              <a:t>Say all four out loud. A panel that hears you name your own limits stops hunting for them.</a:t>
             </a:r>
             <a:endParaRPr lang="en-US" dirty="0"/>
           </a:p>
@@ -1555,6 +1557,94 @@
             <a:fld id="{F7021451-1387-4CA6-816F-3879F97B5CBC}" type="slidenum">
               <a:rPr lang="en-US"/>
               <a:t>2</a:t>
+            </a:fld>
+            <a:endParaRPr lang="en-US"/>
+          </a:p>
+        </p:txBody>
+      </p:sp>
+    </p:spTree>
+    <p:extLst>
+      <p:ext uri="{BB962C8B-B14F-4D97-AF65-F5344CB8AC3E}">
+        <p14:creationId xmlns:p14="http://schemas.microsoft.com/office/powerpoint/2010/main" val="1024086991"/>
+      </p:ext>
+    </p:extLst>
+  </p:cSld>
+  <p:clrMapOvr>
+    <a:masterClrMapping/>
+  </p:clrMapOvr>
+</p:notes>
+</file>
+
+<file path=ppt/notesSlides/notesSlide20.xml><?xml version="1.0" encoding="utf-8"?>
+<p:notes xmlns:a="http://schemas.openxmlformats.org/drawingml/2006/main" xmlns:r="http://schemas.openxmlformats.org/officeDocument/2006/relationships" xmlns:p="http://schemas.openxmlformats.org/presentationml/2006/main">
+  <p:cSld>
+    <p:spTree>
+      <p:nvGrpSpPr>
+        <p:cNvPr id="1" name=""/>
+        <p:cNvGrpSpPr/>
+        <p:nvPr/>
+      </p:nvGrpSpPr>
+      <p:grpSpPr>
+        <a:xfrm>
+          <a:off x="0" y="0"/>
+          <a:ext cx="0" cy="0"/>
+          <a:chOff x="0" y="0"/>
+          <a:chExt cx="0" cy="0"/>
+        </a:xfrm>
+      </p:grpSpPr>
+      <p:sp>
+        <p:nvSpPr>
+          <p:cNvPr id="2" name="Slide Image Placeholder 1"/>
+          <p:cNvSpPr>
+            <a:spLocks noGrp="1" noRot="1" noChangeAspect="1"/>
+          </p:cNvSpPr>
+          <p:nvPr>
+            <p:ph type="sldImg"/>
+          </p:nvPr>
+        </p:nvSpPr>
+        <p:spPr/>
+      </p:sp>
+      <p:sp>
+        <p:nvSpPr>
+          <p:cNvPr id="3" name="Notes Placeholder 2"/>
+          <p:cNvSpPr>
+            <a:spLocks noGrp="1"/>
+          </p:cNvSpPr>
+          <p:nvPr>
+            <p:ph type="body" idx="1"/>
+          </p:nvPr>
+        </p:nvSpPr>
+        <p:spPr/>
+        <p:txBody>
+          <a:bodyPr/>
+          <a:lstStyle/>
+          <a:p>
+            <a:r>
+              <a:rPr lang="en-US" dirty="0"/>
+              <a:t>Close on the second-to-last line. The project set out to make a predictive AI the player can feel, and the measurement that it works is the deliverable.</a:t>
+            </a:r>
+            <a:endParaRPr lang="en-US" dirty="0"/>
+          </a:p>
+        </p:txBody>
+      </p:sp>
+      <p:sp>
+        <p:nvSpPr>
+          <p:cNvPr id="4" name="Slide Number Placeholder 3"/>
+          <p:cNvSpPr>
+            <a:spLocks noGrp="1"/>
+          </p:cNvSpPr>
+          <p:nvPr>
+            <p:ph type="sldNum" sz="quarter" idx="10"/>
+          </p:nvPr>
+        </p:nvSpPr>
+        <p:spPr/>
+        <p:txBody>
+          <a:bodyPr/>
+          <a:lstStyle/>
+          <a:p>
+            <a:fld id="{F7021451-1387-4CA6-816F-3879F97B5CBC}" type="slidenum">
+              <a:rPr lang="en-US"/>
+              <a:t>20</a:t>
             </a:fld>
             <a:endParaRPr lang="en-US"/>
           </a:p>
@@ -3575,7 +3665,7 @@
                   <a:srgbClr val="FBF9F4"/>
                 </a:solidFill>
               </a:rPr>
-              <a:t>Shivam Kumar Arya  ·  Parth Jaiswal</a:t>
+              <a:t>Shivam Kumar Arya (23BRS1357)  ·  Parth Jaiswal (23BRS1323)</a:t>
             </a:r>
             <a:endParaRPr lang="en-US" sz="1250" dirty="0"/>
           </a:p>
@@ -3592,7 +3682,7 @@
                   <a:srgbClr val="7A7059"/>
                 </a:solidFill>
               </a:rPr>
-              <a:t>B.Tech Computer Science and Engineering (AI &amp; Robotics)  ·  BCSE497J</a:t>
+              <a:t>Team 53  ·  Guide: Prakash B  ·  Panel 88  ·  BCSE497J</a:t>
             </a:r>
             <a:endParaRPr lang="en-US" sz="1250" dirty="0"/>
           </a:p>
@@ -3609,7 +3699,7 @@
                   <a:srgbClr val="7A7059"/>
                 </a:solidFill>
               </a:rPr>
-              <a:t>Vellore Institute of Technology</a:t>
+              <a:t>B.Tech Computer Science and Engineering (AI &amp; Robotics)  ·  Vellore Institute of Technology</a:t>
             </a:r>
             <a:endParaRPr lang="en-US" sz="1250" dirty="0"/>
           </a:p>
@@ -6957,7 +7047,7 @@
                 <a:ea typeface="Cambria" pitchFamily="34" charset="-122"/>
                 <a:cs typeface="Cambria" pitchFamily="34" charset="-120"/>
               </a:rPr>
-              <a:t>What this work does not establish</a:t>
+              <a:t>Who did what</a:t>
             </a:r>
             <a:endParaRPr lang="en-US" sz="3200" dirty="0"/>
           </a:p>
@@ -6998,7 +7088,7 @@
                   <a:srgbClr val="7A7059"/>
                 </a:solidFill>
               </a:rPr>
-              <a:t>Stated plainly, because the limits are a result too.</a:t>
+              <a:t>The project guidelines ask the candidate to distinguish what was added from what was already there. This mirrors Table 1.4 of the report.</a:t>
             </a:r>
             <a:endParaRPr lang="en-US" sz="1500" dirty="0"/>
           </a:p>
@@ -7012,12 +7102,12 @@
         </p:nvSpPr>
         <p:spPr>
           <a:xfrm>
-            <a:off x="585216" y="1874520"/>
-            <a:ext cx="5303520" cy="1783080"/>
+            <a:off x="585216" y="1810512"/>
+            <a:ext cx="5303520" cy="3886200"/>
           </a:xfrm>
           <a:prstGeom prst="roundRect">
             <a:avLst>
-              <a:gd name="adj" fmla="val 2051"/>
+              <a:gd name="adj" fmla="val 941"/>
             </a:avLst>
           </a:prstGeom>
           <a:solidFill>
@@ -7039,7 +7129,7 @@
         </p:nvSpPr>
         <p:spPr>
           <a:xfrm>
-            <a:off x="859536" y="2075688"/>
+            <a:off x="859536" y="2011680"/>
             <a:ext cx="4754880" cy="329184"/>
           </a:xfrm>
           <a:prstGeom prst="rect">
@@ -7058,10 +7148,10 @@
             <a:r>
               <a:rPr lang="en-US" sz="1500" b="1" dirty="0">
                 <a:solidFill>
-                  <a:srgbClr val="C2402F"/>
-                </a:solidFill>
-              </a:rPr>
-              <a:t>Nobody has played it</a:t>
+                  <a:srgbClr val="2A78D6"/>
+                </a:solidFill>
+              </a:rPr>
+              <a:t>Baseline — Shivam Kumar Arya</a:t>
             </a:r>
             <a:endParaRPr lang="en-US" sz="1500" dirty="0"/>
           </a:p>
@@ -7075,8 +7165,8 @@
         </p:nvSpPr>
         <p:spPr>
           <a:xfrm>
-            <a:off x="859536" y="2441448"/>
-            <a:ext cx="4800600" cy="1051560"/>
+            <a:off x="859536" y="2450592"/>
+            <a:ext cx="4800600" cy="3017520"/>
           </a:xfrm>
           <a:prstGeom prst="rect">
             <a:avLst/>
@@ -7088,21 +7178,109 @@
           <a:bodyPr wrap="square" lIns="0" tIns="0" rIns="0" bIns="0" rtlCol="0" anchor="ctr"/>
           <a:lstStyle/>
           <a:p>
-            <a:pPr indent="0" marL="0">
+            <a:pPr marL="342900" indent="-342900">
               <a:lnSpc>
-                <a:spcPts val="1800"/>
+                <a:spcPts val="1600"/>
               </a:lnSpc>
-              <a:buNone/>
-            </a:pPr>
-            <a:r>
-              <a:rPr lang="en-US" sz="1250" dirty="0">
+              <a:spcAft>
+                <a:spcPts val="700"/>
+              </a:spcAft>
+              <a:buSzPct val="100000"/>
+              <a:buChar char="•"/>
+            </a:pPr>
+            <a:r>
+              <a:rPr lang="en-US" sz="1200" dirty="0">
                 <a:solidFill>
                   <a:srgbClr val="0B0A08"/>
                 </a:solidFill>
               </a:rPr>
-              <a:t>Every behavioural parameter — the deviation rate, the writing model — is an assumption. Claims about fear, difficulty and enjoyment are untested.</a:t>
-            </a:r>
-            <a:endParaRPr lang="en-US" sz="1250" dirty="0"/>
+              <a:t>Variable-order predictor, order-1 and uniform baselines</a:t>
+            </a:r>
+            <a:endParaRPr lang="en-US" sz="1200" dirty="0"/>
+          </a:p>
+          <a:p>
+            <a:pPr marL="342900" indent="-342900">
+              <a:lnSpc>
+                <a:spcPts val="1600"/>
+              </a:lnSpc>
+              <a:spcAft>
+                <a:spcPts val="700"/>
+              </a:spcAft>
+              <a:buSzPct val="100000"/>
+              <a:buChar char="•"/>
+            </a:pPr>
+            <a:r>
+              <a:rPr lang="en-US" sz="1200" dirty="0">
+                <a:solidFill>
+                  <a:srgbClr val="0B0A08"/>
+                </a:solidFill>
+              </a:rPr>
+              <a:t>Door sensors and the forward belief filter</a:t>
+            </a:r>
+            <a:endParaRPr lang="en-US" sz="1200" dirty="0"/>
+          </a:p>
+          <a:p>
+            <a:pPr marL="342900" indent="-342900">
+              <a:lnSpc>
+                <a:spcPts val="1600"/>
+              </a:lnSpc>
+              <a:spcAft>
+                <a:spcPts val="700"/>
+              </a:spcAft>
+              <a:buSzPct val="100000"/>
+              <a:buChar char="•"/>
+            </a:pPr>
+            <a:r>
+              <a:rPr lang="en-US" sz="1200" dirty="0">
+                <a:solidFill>
+                  <a:srgbClr val="0B0A08"/>
+                </a:solidFill>
+              </a:rPr>
+              <a:t>Director, counter-moves and the fairness rules</a:t>
+            </a:r>
+            <a:endParaRPr lang="en-US" sz="1200" dirty="0"/>
+          </a:p>
+          <a:p>
+            <a:pPr marL="342900" indent="-342900">
+              <a:lnSpc>
+                <a:spcPts val="1600"/>
+              </a:lnSpc>
+              <a:spcAft>
+                <a:spcPts val="700"/>
+              </a:spcAft>
+              <a:buSzPct val="100000"/>
+              <a:buChar char="•"/>
+            </a:pPr>
+            <a:r>
+              <a:rPr lang="en-US" sz="1200" dirty="0">
+                <a:solidFill>
+                  <a:srgbClr val="0B0A08"/>
+                </a:solidFill>
+              </a:rPr>
+              <a:t>Facility graph, scripted players, evaluation, invariant tests</a:t>
+            </a:r>
+            <a:endParaRPr lang="en-US" sz="1200" dirty="0"/>
+          </a:p>
+          <a:p>
+            <a:pPr marL="342900" indent="-342900">
+              <a:lnSpc>
+                <a:spcPts val="1600"/>
+              </a:lnSpc>
+              <a:spcAft>
+                <a:spcPts val="700"/>
+              </a:spcAft>
+              <a:buSzPct val="100000"/>
+              <a:buChar char="•"/>
+            </a:pPr>
+            <a:r>
+              <a:rPr lang="en-US" sz="1200" dirty="0">
+                <a:solidFill>
+                  <a:srgbClr val="0B0A08"/>
+                </a:solidFill>
+              </a:rPr>
+              <a:t>Door clock, notebook, register, codebooks, hunting, audio, step mode</a:t>
+            </a:r>
+            <a:endParaRPr lang="en-US" sz="1200" dirty="0"/>
           </a:p>
         </p:txBody>
       </p:sp>
@@ -7114,12 +7292,12 @@
         </p:nvSpPr>
         <p:spPr>
           <a:xfrm>
-            <a:off x="6163056" y="1874520"/>
-            <a:ext cx="5303520" cy="1783080"/>
+            <a:off x="6163056" y="1810512"/>
+            <a:ext cx="5303520" cy="3886200"/>
           </a:xfrm>
           <a:prstGeom prst="roundRect">
             <a:avLst>
-              <a:gd name="adj" fmla="val 2051"/>
+              <a:gd name="adj" fmla="val 941"/>
             </a:avLst>
           </a:prstGeom>
           <a:solidFill>
@@ -7141,7 +7319,7 @@
         </p:nvSpPr>
         <p:spPr>
           <a:xfrm>
-            <a:off x="6437376" y="2075688"/>
+            <a:off x="6437376" y="2011680"/>
             <a:ext cx="4754880" cy="329184"/>
           </a:xfrm>
           <a:prstGeom prst="rect">
@@ -7160,10 +7338,10 @@
             <a:r>
               <a:rPr lang="en-US" sz="1500" b="1" dirty="0">
                 <a:solidFill>
-                  <a:srgbClr val="C2402F"/>
-                </a:solidFill>
-              </a:rPr>
-              <a:t>The players are scripted</a:t>
+                  <a:srgbClr val="B2561F"/>
+                </a:solidFill>
+              </a:rPr>
+              <a:t>This work — Parth Jaiswal</a:t>
             </a:r>
             <a:endParaRPr lang="en-US" sz="1500" dirty="0"/>
           </a:p>
@@ -7177,8 +7355,8 @@
         </p:nvSpPr>
         <p:spPr>
           <a:xfrm>
-            <a:off x="6437376" y="2441448"/>
-            <a:ext cx="4800600" cy="1051560"/>
+            <a:off x="6437376" y="2450592"/>
+            <a:ext cx="4800600" cy="3017520"/>
           </a:xfrm>
           <a:prstGeom prst="rect">
             <a:avLst/>
@@ -7190,61 +7368,143 @@
           <a:bodyPr wrap="square" lIns="0" tIns="0" rIns="0" bIns="0" rtlCol="0" anchor="ctr"/>
           <a:lstStyle/>
           <a:p>
-            <a:pPr indent="0" marL="0">
+            <a:pPr marL="342900" indent="-342900">
               <a:lnSpc>
-                <a:spcPts val="1800"/>
+                <a:spcPts val="1600"/>
               </a:lnSpc>
-              <a:buNone/>
-            </a:pPr>
-            <a:r>
-              <a:rPr lang="en-US" sz="1250" dirty="0">
+              <a:spcAft>
+                <a:spcPts val="700"/>
+              </a:spcAft>
+              <a:buSzPct val="100000"/>
+              <a:buChar char="•"/>
+            </a:pPr>
+            <a:r>
+              <a:rPr lang="en-US" sz="1200" dirty="0">
                 <a:solidFill>
                   <a:srgbClr val="0B0A08"/>
                 </a:solidFill>
               </a:rPr>
-              <a:t>A Markov model predicting a scripted agent is a weaker claim than one predicting a person. Human traces are the single highest-value next step.</a:t>
-            </a:r>
-            <a:endParaRPr lang="en-US" sz="1250" dirty="0"/>
-          </a:p>
-        </p:txBody>
-      </p:sp>
-      <p:sp>
-        <p:nvSpPr>
-          <p:cNvPr id="10" name="Shape 8"/>
-          <p:cNvSpPr/>
-          <p:nvPr/>
-        </p:nvSpPr>
-        <p:spPr>
-          <a:xfrm>
-            <a:off x="585216" y="3886200"/>
-            <a:ext cx="5303520" cy="1783080"/>
-          </a:xfrm>
-          <a:prstGeom prst="roundRect">
-            <a:avLst>
-              <a:gd name="adj" fmla="val 2051"/>
-            </a:avLst>
-          </a:prstGeom>
-          <a:solidFill>
-            <a:srgbClr val="FFFFFF"/>
-          </a:solidFill>
-          <a:ln w="9525">
-            <a:solidFill>
-              <a:srgbClr val="DED7C6"/>
-            </a:solidFill>
-            <a:prstDash val="solid"/>
-          </a:ln>
-        </p:spPr>
-      </p:sp>
-      <p:sp>
-        <p:nvSpPr>
-          <p:cNvPr id="11" name="Text 9"/>
+              <a:t>A new facility every run: seeded doors, roles, codes, keywords</a:t>
+            </a:r>
+            <a:endParaRPr lang="en-US" sz="1200" dirty="0"/>
+          </a:p>
+          <a:p>
+            <a:pPr marL="342900" indent="-342900">
+              <a:lnSpc>
+                <a:spcPts val="1600"/>
+              </a:lnSpc>
+              <a:spcAft>
+                <a:spcPts val="700"/>
+              </a:spcAft>
+              <a:buSzPct val="100000"/>
+              <a:buChar char="•"/>
+            </a:pPr>
+            <a:r>
+              <a:rPr lang="en-US" sz="1200" dirty="0">
+                <a:solidFill>
+                  <a:srgbClr val="0B0A08"/>
+                </a:solidFill>
+              </a:rPr>
+              <a:t>The MIMIC antagonist and its row-tearing</a:t>
+            </a:r>
+            <a:endParaRPr lang="en-US" sz="1200" dirty="0"/>
+          </a:p>
+          <a:p>
+            <a:pPr marL="342900" indent="-342900">
+              <a:lnSpc>
+                <a:spcPts val="1600"/>
+              </a:lnSpc>
+              <a:spcAft>
+                <a:spcPts val="700"/>
+              </a:spcAft>
+              <a:buSzPct val="100000"/>
+              <a:buChar char="•"/>
+            </a:pPr>
+            <a:r>
+              <a:rPr lang="en-US" sz="1200" dirty="0">
+                <a:solidFill>
+                  <a:srgbClr val="0B0A08"/>
+                </a:solidFill>
+              </a:rPr>
+              <a:t>Mouse look without pointer capture</a:t>
+            </a:r>
+            <a:endParaRPr lang="en-US" sz="1200" dirty="0"/>
+          </a:p>
+          <a:p>
+            <a:pPr marL="342900" indent="-342900">
+              <a:lnSpc>
+                <a:spcPts val="1600"/>
+              </a:lnSpc>
+              <a:spcAft>
+                <a:spcPts val="700"/>
+              </a:spcAft>
+              <a:buSzPct val="100000"/>
+              <a:buChar char="•"/>
+            </a:pPr>
+            <a:r>
+              <a:rPr lang="en-US" sz="1200" dirty="0">
+                <a:solidFill>
+                  <a:srgbClr val="0B0A08"/>
+                </a:solidFill>
+              </a:rPr>
+              <a:t>Material system, weathered surfaces, emergency lighting, grain</a:t>
+            </a:r>
+            <a:endParaRPr lang="en-US" sz="1200" dirty="0"/>
+          </a:p>
+          <a:p>
+            <a:pPr marL="342900" indent="-342900">
+              <a:lnSpc>
+                <a:spcPts val="1600"/>
+              </a:lnSpc>
+              <a:spcAft>
+                <a:spcPts val="700"/>
+              </a:spcAft>
+              <a:buSzPct val="100000"/>
+              <a:buChar char="•"/>
+            </a:pPr>
+            <a:r>
+              <a:rPr lang="en-US" sz="1200" dirty="0">
+                <a:solidFill>
+                  <a:srgbClr val="0B0A08"/>
+                </a:solidFill>
+              </a:rPr>
+              <a:t>Props, the live uplink screen and the codebook monitor</a:t>
+            </a:r>
+            <a:endParaRPr lang="en-US" sz="1200" dirty="0"/>
+          </a:p>
+          <a:p>
+            <a:pPr marL="342900" indent="-342900">
+              <a:lnSpc>
+                <a:spcPts val="1600"/>
+              </a:lnSpc>
+              <a:spcAft>
+                <a:spcPts val="700"/>
+              </a:spcAft>
+              <a:buSzPct val="100000"/>
+              <a:buChar char="•"/>
+            </a:pPr>
+            <a:r>
+              <a:rPr lang="en-US" sz="1200" dirty="0">
+                <a:solidFill>
+                  <a:srgbClr val="0B0A08"/>
+                </a:solidFill>
+              </a:rPr>
+              <a:t>Watch mode, recording mode and the recorder</a:t>
+            </a:r>
+            <a:endParaRPr lang="en-US" sz="1200" dirty="0"/>
+          </a:p>
+        </p:txBody>
+      </p:sp>
+      <p:sp>
+        <p:nvSpPr>
+          <p:cNvPr id="10" name="Text 8"/>
           <p:cNvSpPr txBox="1"/>
           <p:nvPr/>
         </p:nvSpPr>
         <p:spPr>
           <a:xfrm>
-            <a:off x="859536" y="4087368"/>
-            <a:ext cx="4754880" cy="329184"/>
+            <a:off x="585216" y="5797296"/>
+            <a:ext cx="10936224" cy="320040"/>
           </a:xfrm>
           <a:prstGeom prst="rect">
             <a:avLst/>
@@ -7260,161 +7520,20 @@
               <a:buNone/>
             </a:pPr>
             <a:r>
-              <a:rPr lang="en-US" sz="1500" b="1" dirty="0">
-                <a:solidFill>
-                  <a:srgbClr val="C2402F"/>
-                </a:solidFill>
-              </a:rPr>
-              <a:t>Memory does not transfer</a:t>
-            </a:r>
-            <a:endParaRPr lang="en-US" sz="1500" dirty="0"/>
-          </a:p>
-        </p:txBody>
-      </p:sp>
-      <p:sp>
-        <p:nvSpPr>
-          <p:cNvPr id="12" name="Text 10"/>
-          <p:cNvSpPr txBox="1"/>
-          <p:nvPr/>
-        </p:nvSpPr>
-        <p:spPr>
-          <a:xfrm>
-            <a:off x="859536" y="4453128"/>
-            <a:ext cx="4800600" cy="1051560"/>
-          </a:xfrm>
-          <a:prstGeom prst="rect">
-            <a:avLst/>
-          </a:prstGeom>
-          <a:noFill/>
-          <a:ln/>
-        </p:spPr>
-        <p:txBody>
-          <a:bodyPr wrap="square" lIns="0" tIns="0" rIns="0" bIns="0" rtlCol="0" anchor="ctr"/>
-          <a:lstStyle/>
-          <a:p>
-            <a:pPr indent="0" marL="0">
-              <a:lnSpc>
-                <a:spcPts val="1800"/>
-              </a:lnSpc>
-              <a:buNone/>
-            </a:pPr>
-            <a:r>
-              <a:rPr lang="en-US" sz="1250" dirty="0">
-                <a:solidFill>
-                  <a:srgbClr val="0B0A08"/>
-                </a:solidFill>
-              </a:rPr>
-              <a:t>Retained learning helps in a fixed building and hurts in a regenerated one. The predictor is keyed on room indices, and an index stops meaning the same thing.</a:t>
-            </a:r>
-            <a:endParaRPr lang="en-US" sz="1250" dirty="0"/>
-          </a:p>
-        </p:txBody>
-      </p:sp>
-      <p:sp>
-        <p:nvSpPr>
-          <p:cNvPr id="13" name="Shape 11"/>
-          <p:cNvSpPr/>
-          <p:nvPr/>
-        </p:nvSpPr>
-        <p:spPr>
-          <a:xfrm>
-            <a:off x="6163056" y="3886200"/>
-            <a:ext cx="5303520" cy="1783080"/>
-          </a:xfrm>
-          <a:prstGeom prst="roundRect">
-            <a:avLst>
-              <a:gd name="adj" fmla="val 2051"/>
-            </a:avLst>
-          </a:prstGeom>
-          <a:solidFill>
-            <a:srgbClr val="FFFFFF"/>
-          </a:solidFill>
-          <a:ln w="9525">
-            <a:solidFill>
-              <a:srgbClr val="DED7C6"/>
-            </a:solidFill>
-            <a:prstDash val="solid"/>
-          </a:ln>
-        </p:spPr>
-      </p:sp>
-      <p:sp>
-        <p:nvSpPr>
-          <p:cNvPr id="14" name="Text 12"/>
-          <p:cNvSpPr txBox="1"/>
-          <p:nvPr/>
-        </p:nvSpPr>
-        <p:spPr>
-          <a:xfrm>
-            <a:off x="6437376" y="4087368"/>
-            <a:ext cx="4754880" cy="329184"/>
-          </a:xfrm>
-          <a:prstGeom prst="rect">
-            <a:avLst/>
-          </a:prstGeom>
-          <a:noFill/>
-          <a:ln/>
-        </p:spPr>
-        <p:txBody>
-          <a:bodyPr wrap="square" lIns="0" tIns="0" rIns="0" bIns="0" rtlCol="0" anchor="ctr"/>
-          <a:lstStyle/>
-          <a:p>
-            <a:pPr indent="0" marL="0">
-              <a:buNone/>
-            </a:pPr>
-            <a:r>
-              <a:rPr lang="en-US" sz="1500" b="1" dirty="0">
-                <a:solidFill>
-                  <a:srgbClr val="C2402F"/>
-                </a:solidFill>
-              </a:rPr>
-              <a:t>Dwell is unsolved</a:t>
-            </a:r>
-            <a:endParaRPr lang="en-US" sz="1500" dirty="0"/>
-          </a:p>
-        </p:txBody>
-      </p:sp>
-      <p:sp>
-        <p:nvSpPr>
-          <p:cNvPr id="15" name="Text 13"/>
-          <p:cNvSpPr txBox="1"/>
-          <p:nvPr/>
-        </p:nvSpPr>
-        <p:spPr>
-          <a:xfrm>
-            <a:off x="6437376" y="4453128"/>
-            <a:ext cx="4800600" cy="1051560"/>
-          </a:xfrm>
-          <a:prstGeom prst="rect">
-            <a:avLst/>
-          </a:prstGeom>
-          <a:noFill/>
-          <a:ln/>
-        </p:spPr>
-        <p:txBody>
-          <a:bodyPr wrap="square" lIns="0" tIns="0" rIns="0" bIns="0" rtlCol="0" anchor="ctr"/>
-          <a:lstStyle/>
-          <a:p>
-            <a:pPr indent="0" marL="0">
-              <a:lnSpc>
-                <a:spcPts val="1800"/>
-              </a:lnSpc>
-              <a:buNone/>
-            </a:pPr>
-            <a:r>
-              <a:rPr lang="en-US" sz="1250" dirty="0">
-                <a:solidFill>
-                  <a:srgbClr val="0B0A08"/>
-                </a:solidFill>
-              </a:rPr>
-              <a:t>16.8% recall on the moment the player stops to write, after four failed attempts to improve it.</a:t>
-            </a:r>
-            <a:endParaRPr lang="en-US" sz="1250" dirty="0"/>
-          </a:p>
-        </p:txBody>
-      </p:sp>
-      <p:sp>
-        <p:nvSpPr>
-          <p:cNvPr id="17" name="Text 1"/>
+              <a:rPr lang="en-US" sz="1150" i="1" dirty="0">
+                <a:solidFill>
+                  <a:srgbClr val="7A7059"/>
+                </a:solidFill>
+              </a:rPr>
+              <a:t>E13, the cross-session measurement in §7.8, was added to the baseline evaluation suite after the fork.</a:t>
+            </a:r>
+            <a:endParaRPr lang="en-US" sz="1150" dirty="0"/>
+          </a:p>
+        </p:txBody>
+      </p:sp>
+      <p:sp>
+        <p:nvSpPr>
+          <p:cNvPr id="12" name="Text 1"/>
           <p:cNvSpPr/>
           <p:nvPr>
             <p:ph idx="103" hasCustomPrompt="1"/>
@@ -7477,34 +7596,34 @@
         </p:nvSpPr>
         <p:spPr>
           <a:xfrm>
-            <a:off x="822960" y="1371600"/>
-            <a:ext cx="10515600" cy="914400"/>
-          </a:xfrm>
-          <a:prstGeom prst="rect">
-            <a:avLst/>
-          </a:prstGeom>
-          <a:noFill/>
-          <a:ln/>
-        </p:spPr>
-        <p:txBody>
-          <a:bodyPr wrap="square" rtlCol="0"/>
+            <a:off x="566928" y="384048"/>
+            <a:ext cx="11064240" cy="713232"/>
+          </a:xfrm>
+          <a:prstGeom prst="rect">
+            <a:avLst/>
+          </a:prstGeom>
+          <a:noFill/>
+          <a:ln/>
+        </p:spPr>
+        <p:txBody>
+          <a:bodyPr wrap="square" lIns="0" tIns="0" rIns="0" bIns="0" rtlCol="0"/>
           <a:lstStyle/>
           <a:p>
             <a:pPr algn="l" indent="0" marL="0">
               <a:buNone/>
             </a:pPr>
             <a:r>
-              <a:rPr lang="en-US" sz="3800" b="1" dirty="0">
-                <a:solidFill>
-                  <a:srgbClr val="FFB545"/>
+              <a:rPr lang="en-US" sz="3200" b="1" dirty="0">
+                <a:solidFill>
+                  <a:srgbClr val="0B0A08"/>
                 </a:solidFill>
                 <a:latin typeface="Cambria" pitchFamily="34" charset="0"/>
                 <a:ea typeface="Cambria" pitchFamily="34" charset="-122"/>
                 <a:cs typeface="Cambria" pitchFamily="34" charset="-120"/>
               </a:rPr>
-              <a:t>Where it stands</a:t>
-            </a:r>
-            <a:endParaRPr lang="en-US" sz="3800" dirty="0"/>
+              <a:t>What this work does not establish</a:t>
+            </a:r>
+            <a:endParaRPr lang="en-US" sz="3200" dirty="0"/>
           </a:p>
         </p:txBody>
       </p:sp>
@@ -7518,8 +7637,457 @@
         </p:nvSpPr>
         <p:spPr>
           <a:xfrm>
-            <a:off x="868680" y="2212848"/>
-            <a:ext cx="10332720" cy="3611880"/>
+            <a:off x="585216" y="1115568"/>
+            <a:ext cx="10972800" cy="566928"/>
+          </a:xfrm>
+          <a:prstGeom prst="rect">
+            <a:avLst/>
+          </a:prstGeom>
+          <a:noFill/>
+          <a:ln/>
+        </p:spPr>
+        <p:txBody>
+          <a:bodyPr wrap="square" lIns="0" tIns="0" rIns="0" bIns="0" rtlCol="0"/>
+          <a:lstStyle/>
+          <a:p>
+            <a:pPr indent="0" marL="0">
+              <a:lnSpc>
+                <a:spcPts val="2200"/>
+              </a:lnSpc>
+              <a:buNone/>
+            </a:pPr>
+            <a:r>
+              <a:rPr lang="en-US" sz="1500" dirty="0">
+                <a:solidFill>
+                  <a:srgbClr val="7A7059"/>
+                </a:solidFill>
+              </a:rPr>
+              <a:t>Stated plainly, because the limits are a result too.</a:t>
+            </a:r>
+            <a:endParaRPr lang="en-US" sz="1500" dirty="0"/>
+          </a:p>
+        </p:txBody>
+      </p:sp>
+      <p:sp>
+        <p:nvSpPr>
+          <p:cNvPr id="4" name="Shape 2"/>
+          <p:cNvSpPr/>
+          <p:nvPr/>
+        </p:nvSpPr>
+        <p:spPr>
+          <a:xfrm>
+            <a:off x="585216" y="1874520"/>
+            <a:ext cx="5303520" cy="1783080"/>
+          </a:xfrm>
+          <a:prstGeom prst="roundRect">
+            <a:avLst>
+              <a:gd name="adj" fmla="val 2051"/>
+            </a:avLst>
+          </a:prstGeom>
+          <a:solidFill>
+            <a:srgbClr val="FFFFFF"/>
+          </a:solidFill>
+          <a:ln w="9525">
+            <a:solidFill>
+              <a:srgbClr val="DED7C6"/>
+            </a:solidFill>
+            <a:prstDash val="solid"/>
+          </a:ln>
+        </p:spPr>
+      </p:sp>
+      <p:sp>
+        <p:nvSpPr>
+          <p:cNvPr id="5" name="Text 3"/>
+          <p:cNvSpPr txBox="1"/>
+          <p:nvPr/>
+        </p:nvSpPr>
+        <p:spPr>
+          <a:xfrm>
+            <a:off x="859536" y="2075688"/>
+            <a:ext cx="4754880" cy="329184"/>
+          </a:xfrm>
+          <a:prstGeom prst="rect">
+            <a:avLst/>
+          </a:prstGeom>
+          <a:noFill/>
+          <a:ln/>
+        </p:spPr>
+        <p:txBody>
+          <a:bodyPr wrap="square" lIns="0" tIns="0" rIns="0" bIns="0" rtlCol="0" anchor="ctr"/>
+          <a:lstStyle/>
+          <a:p>
+            <a:pPr indent="0" marL="0">
+              <a:buNone/>
+            </a:pPr>
+            <a:r>
+              <a:rPr lang="en-US" sz="1500" b="1" dirty="0">
+                <a:solidFill>
+                  <a:srgbClr val="C2402F"/>
+                </a:solidFill>
+              </a:rPr>
+              <a:t>Nobody has played it</a:t>
+            </a:r>
+            <a:endParaRPr lang="en-US" sz="1500" dirty="0"/>
+          </a:p>
+        </p:txBody>
+      </p:sp>
+      <p:sp>
+        <p:nvSpPr>
+          <p:cNvPr id="6" name="Text 4"/>
+          <p:cNvSpPr txBox="1"/>
+          <p:nvPr/>
+        </p:nvSpPr>
+        <p:spPr>
+          <a:xfrm>
+            <a:off x="859536" y="2441448"/>
+            <a:ext cx="4800600" cy="1051560"/>
+          </a:xfrm>
+          <a:prstGeom prst="rect">
+            <a:avLst/>
+          </a:prstGeom>
+          <a:noFill/>
+          <a:ln/>
+        </p:spPr>
+        <p:txBody>
+          <a:bodyPr wrap="square" lIns="0" tIns="0" rIns="0" bIns="0" rtlCol="0" anchor="ctr"/>
+          <a:lstStyle/>
+          <a:p>
+            <a:pPr indent="0" marL="0">
+              <a:lnSpc>
+                <a:spcPts val="1800"/>
+              </a:lnSpc>
+              <a:buNone/>
+            </a:pPr>
+            <a:r>
+              <a:rPr lang="en-US" sz="1250" dirty="0">
+                <a:solidFill>
+                  <a:srgbClr val="0B0A08"/>
+                </a:solidFill>
+              </a:rPr>
+              <a:t>Every behavioural parameter — the deviation rate, the writing model — is an assumption. Claims about fear, difficulty and enjoyment are untested.</a:t>
+            </a:r>
+            <a:endParaRPr lang="en-US" sz="1250" dirty="0"/>
+          </a:p>
+        </p:txBody>
+      </p:sp>
+      <p:sp>
+        <p:nvSpPr>
+          <p:cNvPr id="7" name="Shape 5"/>
+          <p:cNvSpPr/>
+          <p:nvPr/>
+        </p:nvSpPr>
+        <p:spPr>
+          <a:xfrm>
+            <a:off x="6163056" y="1874520"/>
+            <a:ext cx="5303520" cy="1783080"/>
+          </a:xfrm>
+          <a:prstGeom prst="roundRect">
+            <a:avLst>
+              <a:gd name="adj" fmla="val 2051"/>
+            </a:avLst>
+          </a:prstGeom>
+          <a:solidFill>
+            <a:srgbClr val="FFFFFF"/>
+          </a:solidFill>
+          <a:ln w="9525">
+            <a:solidFill>
+              <a:srgbClr val="DED7C6"/>
+            </a:solidFill>
+            <a:prstDash val="solid"/>
+          </a:ln>
+        </p:spPr>
+      </p:sp>
+      <p:sp>
+        <p:nvSpPr>
+          <p:cNvPr id="8" name="Text 6"/>
+          <p:cNvSpPr txBox="1"/>
+          <p:nvPr/>
+        </p:nvSpPr>
+        <p:spPr>
+          <a:xfrm>
+            <a:off x="6437376" y="2075688"/>
+            <a:ext cx="4754880" cy="329184"/>
+          </a:xfrm>
+          <a:prstGeom prst="rect">
+            <a:avLst/>
+          </a:prstGeom>
+          <a:noFill/>
+          <a:ln/>
+        </p:spPr>
+        <p:txBody>
+          <a:bodyPr wrap="square" lIns="0" tIns="0" rIns="0" bIns="0" rtlCol="0" anchor="ctr"/>
+          <a:lstStyle/>
+          <a:p>
+            <a:pPr indent="0" marL="0">
+              <a:buNone/>
+            </a:pPr>
+            <a:r>
+              <a:rPr lang="en-US" sz="1500" b="1" dirty="0">
+                <a:solidFill>
+                  <a:srgbClr val="C2402F"/>
+                </a:solidFill>
+              </a:rPr>
+              <a:t>The players are scripted</a:t>
+            </a:r>
+            <a:endParaRPr lang="en-US" sz="1500" dirty="0"/>
+          </a:p>
+        </p:txBody>
+      </p:sp>
+      <p:sp>
+        <p:nvSpPr>
+          <p:cNvPr id="9" name="Text 7"/>
+          <p:cNvSpPr txBox="1"/>
+          <p:nvPr/>
+        </p:nvSpPr>
+        <p:spPr>
+          <a:xfrm>
+            <a:off x="6437376" y="2441448"/>
+            <a:ext cx="4800600" cy="1051560"/>
+          </a:xfrm>
+          <a:prstGeom prst="rect">
+            <a:avLst/>
+          </a:prstGeom>
+          <a:noFill/>
+          <a:ln/>
+        </p:spPr>
+        <p:txBody>
+          <a:bodyPr wrap="square" lIns="0" tIns="0" rIns="0" bIns="0" rtlCol="0" anchor="ctr"/>
+          <a:lstStyle/>
+          <a:p>
+            <a:pPr indent="0" marL="0">
+              <a:lnSpc>
+                <a:spcPts val="1800"/>
+              </a:lnSpc>
+              <a:buNone/>
+            </a:pPr>
+            <a:r>
+              <a:rPr lang="en-US" sz="1250" dirty="0">
+                <a:solidFill>
+                  <a:srgbClr val="0B0A08"/>
+                </a:solidFill>
+              </a:rPr>
+              <a:t>A Markov model predicting a scripted agent is a weaker claim than one predicting a person. Human traces are the single highest-value next step.</a:t>
+            </a:r>
+            <a:endParaRPr lang="en-US" sz="1250" dirty="0"/>
+          </a:p>
+        </p:txBody>
+      </p:sp>
+      <p:sp>
+        <p:nvSpPr>
+          <p:cNvPr id="10" name="Shape 8"/>
+          <p:cNvSpPr/>
+          <p:nvPr/>
+        </p:nvSpPr>
+        <p:spPr>
+          <a:xfrm>
+            <a:off x="585216" y="3886200"/>
+            <a:ext cx="5303520" cy="1783080"/>
+          </a:xfrm>
+          <a:prstGeom prst="roundRect">
+            <a:avLst>
+              <a:gd name="adj" fmla="val 2051"/>
+            </a:avLst>
+          </a:prstGeom>
+          <a:solidFill>
+            <a:srgbClr val="FFFFFF"/>
+          </a:solidFill>
+          <a:ln w="9525">
+            <a:solidFill>
+              <a:srgbClr val="DED7C6"/>
+            </a:solidFill>
+            <a:prstDash val="solid"/>
+          </a:ln>
+        </p:spPr>
+      </p:sp>
+      <p:sp>
+        <p:nvSpPr>
+          <p:cNvPr id="11" name="Text 9"/>
+          <p:cNvSpPr txBox="1"/>
+          <p:nvPr/>
+        </p:nvSpPr>
+        <p:spPr>
+          <a:xfrm>
+            <a:off x="859536" y="4087368"/>
+            <a:ext cx="4754880" cy="329184"/>
+          </a:xfrm>
+          <a:prstGeom prst="rect">
+            <a:avLst/>
+          </a:prstGeom>
+          <a:noFill/>
+          <a:ln/>
+        </p:spPr>
+        <p:txBody>
+          <a:bodyPr wrap="square" lIns="0" tIns="0" rIns="0" bIns="0" rtlCol="0" anchor="ctr"/>
+          <a:lstStyle/>
+          <a:p>
+            <a:pPr indent="0" marL="0">
+              <a:buNone/>
+            </a:pPr>
+            <a:r>
+              <a:rPr lang="en-US" sz="1500" b="1" dirty="0">
+                <a:solidFill>
+                  <a:srgbClr val="C2402F"/>
+                </a:solidFill>
+              </a:rPr>
+              <a:t>Memory does not transfer</a:t>
+            </a:r>
+            <a:endParaRPr lang="en-US" sz="1500" dirty="0"/>
+          </a:p>
+        </p:txBody>
+      </p:sp>
+      <p:sp>
+        <p:nvSpPr>
+          <p:cNvPr id="12" name="Text 10"/>
+          <p:cNvSpPr txBox="1"/>
+          <p:nvPr/>
+        </p:nvSpPr>
+        <p:spPr>
+          <a:xfrm>
+            <a:off x="859536" y="4453128"/>
+            <a:ext cx="4800600" cy="1051560"/>
+          </a:xfrm>
+          <a:prstGeom prst="rect">
+            <a:avLst/>
+          </a:prstGeom>
+          <a:noFill/>
+          <a:ln/>
+        </p:spPr>
+        <p:txBody>
+          <a:bodyPr wrap="square" lIns="0" tIns="0" rIns="0" bIns="0" rtlCol="0" anchor="ctr"/>
+          <a:lstStyle/>
+          <a:p>
+            <a:pPr indent="0" marL="0">
+              <a:lnSpc>
+                <a:spcPts val="1800"/>
+              </a:lnSpc>
+              <a:buNone/>
+            </a:pPr>
+            <a:r>
+              <a:rPr lang="en-US" sz="1250" dirty="0">
+                <a:solidFill>
+                  <a:srgbClr val="0B0A08"/>
+                </a:solidFill>
+              </a:rPr>
+              <a:t>Retained learning helps in a fixed building and hurts in a regenerated one. The predictor is keyed on room indices, and an index stops meaning the same thing.</a:t>
+            </a:r>
+            <a:endParaRPr lang="en-US" sz="1250" dirty="0"/>
+          </a:p>
+        </p:txBody>
+      </p:sp>
+      <p:sp>
+        <p:nvSpPr>
+          <p:cNvPr id="13" name="Shape 11"/>
+          <p:cNvSpPr/>
+          <p:nvPr/>
+        </p:nvSpPr>
+        <p:spPr>
+          <a:xfrm>
+            <a:off x="6163056" y="3886200"/>
+            <a:ext cx="5303520" cy="1783080"/>
+          </a:xfrm>
+          <a:prstGeom prst="roundRect">
+            <a:avLst>
+              <a:gd name="adj" fmla="val 2051"/>
+            </a:avLst>
+          </a:prstGeom>
+          <a:solidFill>
+            <a:srgbClr val="FFFFFF"/>
+          </a:solidFill>
+          <a:ln w="9525">
+            <a:solidFill>
+              <a:srgbClr val="DED7C6"/>
+            </a:solidFill>
+            <a:prstDash val="solid"/>
+          </a:ln>
+        </p:spPr>
+      </p:sp>
+      <p:sp>
+        <p:nvSpPr>
+          <p:cNvPr id="14" name="Text 12"/>
+          <p:cNvSpPr txBox="1"/>
+          <p:nvPr/>
+        </p:nvSpPr>
+        <p:spPr>
+          <a:xfrm>
+            <a:off x="6437376" y="4087368"/>
+            <a:ext cx="4754880" cy="329184"/>
+          </a:xfrm>
+          <a:prstGeom prst="rect">
+            <a:avLst/>
+          </a:prstGeom>
+          <a:noFill/>
+          <a:ln/>
+        </p:spPr>
+        <p:txBody>
+          <a:bodyPr wrap="square" lIns="0" tIns="0" rIns="0" bIns="0" rtlCol="0" anchor="ctr"/>
+          <a:lstStyle/>
+          <a:p>
+            <a:pPr indent="0" marL="0">
+              <a:buNone/>
+            </a:pPr>
+            <a:r>
+              <a:rPr lang="en-US" sz="1500" b="1" dirty="0">
+                <a:solidFill>
+                  <a:srgbClr val="C2402F"/>
+                </a:solidFill>
+              </a:rPr>
+              <a:t>Dwell is unsolved</a:t>
+            </a:r>
+            <a:endParaRPr lang="en-US" sz="1500" dirty="0"/>
+          </a:p>
+        </p:txBody>
+      </p:sp>
+      <p:sp>
+        <p:nvSpPr>
+          <p:cNvPr id="15" name="Text 13"/>
+          <p:cNvSpPr txBox="1"/>
+          <p:nvPr/>
+        </p:nvSpPr>
+        <p:spPr>
+          <a:xfrm>
+            <a:off x="6437376" y="4453128"/>
+            <a:ext cx="4800600" cy="1051560"/>
+          </a:xfrm>
+          <a:prstGeom prst="rect">
+            <a:avLst/>
+          </a:prstGeom>
+          <a:noFill/>
+          <a:ln/>
+        </p:spPr>
+        <p:txBody>
+          <a:bodyPr wrap="square" lIns="0" tIns="0" rIns="0" bIns="0" rtlCol="0" anchor="ctr"/>
+          <a:lstStyle/>
+          <a:p>
+            <a:pPr indent="0" marL="0">
+              <a:lnSpc>
+                <a:spcPts val="1800"/>
+              </a:lnSpc>
+              <a:buNone/>
+            </a:pPr>
+            <a:r>
+              <a:rPr lang="en-US" sz="1250" dirty="0">
+                <a:solidFill>
+                  <a:srgbClr val="0B0A08"/>
+                </a:solidFill>
+              </a:rPr>
+              <a:t>16.8% recall on the moment the player stops to write, after four failed attempts to improve it.</a:t>
+            </a:r>
+            <a:endParaRPr lang="en-US" sz="1250" dirty="0"/>
+          </a:p>
+        </p:txBody>
+      </p:sp>
+      <p:sp>
+        <p:nvSpPr>
+          <p:cNvPr id="17" name="Text 1"/>
+          <p:cNvSpPr/>
+          <p:nvPr>
+            <p:ph idx="103" hasCustomPrompt="1"/>
+          </p:nvPr>
+        </p:nvSpPr>
+        <p:spPr>
+          <a:xfrm>
+            <a:off x="11247120" y="6327648"/>
+            <a:ext cx="457200" cy="274320"/>
           </a:xfrm>
           <a:prstGeom prst="rect">
             <a:avLst/>
@@ -7531,138 +8099,10 @@
           <a:bodyPr wrap="square" rtlCol="0"/>
           <a:lstStyle/>
           <a:p>
-            <a:pPr algn="l" indent="0" marL="0">
-              <a:lnSpc>
-                <a:spcPts val="2500"/>
-              </a:lnSpc>
-              <a:buNone/>
-            </a:pPr>
-            <a:r>
-              <a:rPr lang="en-US" sz="1500" b="1" dirty="0">
-                <a:solidFill>
-                  <a:srgbClr val="FBF9F4"/>
-                </a:solidFill>
-              </a:rPr>
-              <a:t>A horror antagonist that models the individual player, and a measurement that says how well.</a:t>
-            </a:r>
-            <a:endParaRPr lang="en-US" sz="1500" dirty="0"/>
-          </a:p>
-          <a:p>
-            <a:pPr algn="l" indent="0" marL="0">
-              <a:lnSpc>
-                <a:spcPts val="2500"/>
-              </a:lnSpc>
-              <a:buNone/>
-            </a:pPr>
-            <a:endParaRPr lang="en-US" sz="1500" dirty="0"/>
-          </a:p>
-          <a:p>
-            <a:pPr algn="l" indent="0" marL="0">
-              <a:lnSpc>
-                <a:spcPts val="2500"/>
-              </a:lnSpc>
-              <a:buNone/>
-            </a:pPr>
-            <a:r>
-              <a:rPr lang="en-US" sz="1500" dirty="0">
-                <a:solidFill>
-                  <a:srgbClr val="FBF9F4"/>
-                </a:solidFill>
-              </a:rPr>
-              <a:t>It predicts the next room 83.6% of the time against a habitual player, and 26.7% against one with no habits — which is exactly what having no model scores. The gain is learned behaviour, not leakage. Against an oracle that can see the player's internal state, it reaches 97% of the achievable signal from behaviour alone.</a:t>
-            </a:r>
-            <a:endParaRPr lang="en-US" sz="1500" dirty="0"/>
-          </a:p>
-          <a:p>
-            <a:pPr algn="l" indent="0" marL="0">
-              <a:lnSpc>
-                <a:spcPts val="2500"/>
-              </a:lnSpc>
-              <a:buNone/>
-            </a:pPr>
-            <a:endParaRPr lang="en-US" sz="1500" dirty="0"/>
-          </a:p>
-          <a:p>
-            <a:pPr algn="l" indent="0" marL="0">
-              <a:lnSpc>
-                <a:spcPts val="2500"/>
-              </a:lnSpc>
-              <a:buNone/>
-            </a:pPr>
-            <a:r>
-              <a:rPr lang="en-US" sz="1500" b="1" dirty="0">
-                <a:solidFill>
-                  <a:srgbClr val="FFB545"/>
-                </a:solidFill>
-              </a:rPr>
-              <a:t>It gets better at catching a returning player, and we now know the one condition where it does not.</a:t>
-            </a:r>
-            <a:endParaRPr lang="en-US" sz="1500" dirty="0"/>
-          </a:p>
-          <a:p>
-            <a:pPr algn="l" indent="0" marL="0">
-              <a:lnSpc>
-                <a:spcPts val="2500"/>
-              </a:lnSpc>
-              <a:buNone/>
-            </a:pPr>
-            <a:endParaRPr lang="en-US" sz="1500" dirty="0"/>
-          </a:p>
-          <a:p>
-            <a:pPr algn="l" indent="0" marL="0">
-              <a:lnSpc>
-                <a:spcPts val="2500"/>
-              </a:lnSpc>
-              <a:buNone/>
-            </a:pPr>
-            <a:r>
-              <a:rPr lang="en-US" sz="1500" dirty="0">
-                <a:solidFill>
-                  <a:srgbClr val="7A7059"/>
-                </a:solidFill>
-              </a:rPr>
-              <a:t>Next: human playtest traces in place of scripted players, and a predictor re-keyed on features that survive a rewired building.</a:t>
-            </a:r>
-            <a:endParaRPr lang="en-US" sz="1500" dirty="0"/>
-          </a:p>
-        </p:txBody>
-      </p:sp>
-      <p:sp>
-        <p:nvSpPr>
-          <p:cNvPr id="4" name="Text 2"/>
-          <p:cNvSpPr txBox="1"/>
-          <p:nvPr/>
-        </p:nvSpPr>
-        <p:spPr>
-          <a:xfrm>
-            <a:off x="868680" y="6236208"/>
-            <a:ext cx="6400800" cy="320040"/>
-          </a:xfrm>
-          <a:prstGeom prst="rect">
-            <a:avLst/>
-          </a:prstGeom>
-          <a:noFill/>
-          <a:ln/>
-        </p:spPr>
-        <p:txBody>
-          <a:bodyPr wrap="square" lIns="0" tIns="0" rIns="0" bIns="0" rtlCol="0" anchor="ctr"/>
-          <a:lstStyle/>
-          <a:p>
-            <a:pPr indent="0" marL="0">
-              <a:buNone/>
-            </a:pPr>
-            <a:r>
-              <a:rPr lang="en-US" sz="1250" dirty="0">
-                <a:solidFill>
-                  <a:srgbClr val="7A7059"/>
-                </a:solidFill>
-                <a:latin typeface="Courier New" pitchFamily="34" charset="0"/>
-                <a:ea typeface="Courier New" pitchFamily="34" charset="-122"/>
-                <a:cs typeface="Courier New" pitchFamily="34" charset="-120"/>
-              </a:rPr>
-              <a:t>github.com/Sh1v4mKum4r/parity</a:t>
-            </a:r>
-            <a:endParaRPr lang="en-US" sz="1250" dirty="0"/>
+            <a:pPr algn="r" indent="0" marL="0">
+              <a:buNone/>
+            </a:pPr>
+            <a:endParaRPr lang="en-US" sz="950" dirty="0"/>
           </a:p>
         </p:txBody>
       </p:sp>
@@ -7808,6 +8248,230 @@
               <a:t>Game AI has optimised for competence. Adaptation to the individual player is the less-solved half.</a:t>
             </a:r>
             <a:endParaRPr lang="en-US" sz="1500" dirty="0"/>
+          </a:p>
+        </p:txBody>
+      </p:sp>
+    </p:spTree>
+  </p:cSld>
+  <p:clrMapOvr>
+    <a:masterClrMapping/>
+  </p:clrMapOvr>
+</p:sld>
+</file>
+
+<file path=ppt/slides/slide20.xml><?xml version="1.0" encoding="utf-8"?>
+<p:sld xmlns:a="http://schemas.openxmlformats.org/drawingml/2006/main" xmlns:r="http://schemas.openxmlformats.org/officeDocument/2006/relationships" xmlns:p="http://schemas.openxmlformats.org/presentationml/2006/main">
+  <p:cSld name="Slide 20">
+    <p:spTree>
+      <p:nvGrpSpPr>
+        <p:cNvPr id="1" name=""/>
+        <p:cNvGrpSpPr/>
+        <p:nvPr/>
+      </p:nvGrpSpPr>
+      <p:grpSpPr>
+        <a:xfrm>
+          <a:off x="0" y="0"/>
+          <a:ext cx="0" cy="0"/>
+          <a:chOff x="0" y="0"/>
+          <a:chExt cx="0" cy="0"/>
+        </a:xfrm>
+      </p:grpSpPr>
+      <p:sp>
+        <p:nvSpPr>
+          <p:cNvPr id="2" name="Text 0"/>
+          <p:cNvSpPr/>
+          <p:nvPr>
+            <p:ph idx="100" type="title" hasCustomPrompt="1"/>
+          </p:nvPr>
+        </p:nvSpPr>
+        <p:spPr>
+          <a:xfrm>
+            <a:off x="822960" y="1371600"/>
+            <a:ext cx="10515600" cy="914400"/>
+          </a:xfrm>
+          <a:prstGeom prst="rect">
+            <a:avLst/>
+          </a:prstGeom>
+          <a:noFill/>
+          <a:ln/>
+        </p:spPr>
+        <p:txBody>
+          <a:bodyPr wrap="square" rtlCol="0"/>
+          <a:lstStyle/>
+          <a:p>
+            <a:pPr algn="l" indent="0" marL="0">
+              <a:buNone/>
+            </a:pPr>
+            <a:r>
+              <a:rPr lang="en-US" sz="3800" b="1" dirty="0">
+                <a:solidFill>
+                  <a:srgbClr val="FFB545"/>
+                </a:solidFill>
+                <a:latin typeface="Cambria" pitchFamily="34" charset="0"/>
+                <a:ea typeface="Cambria" pitchFamily="34" charset="-122"/>
+                <a:cs typeface="Cambria" pitchFamily="34" charset="-120"/>
+              </a:rPr>
+              <a:t>Where it stands</a:t>
+            </a:r>
+            <a:endParaRPr lang="en-US" sz="3800" dirty="0"/>
+          </a:p>
+        </p:txBody>
+      </p:sp>
+      <p:sp>
+        <p:nvSpPr>
+          <p:cNvPr id="3" name="Text 0"/>
+          <p:cNvSpPr/>
+          <p:nvPr>
+            <p:ph idx="101" type="body" hasCustomPrompt="1"/>
+          </p:nvPr>
+        </p:nvSpPr>
+        <p:spPr>
+          <a:xfrm>
+            <a:off x="868680" y="2212848"/>
+            <a:ext cx="10332720" cy="3611880"/>
+          </a:xfrm>
+          <a:prstGeom prst="rect">
+            <a:avLst/>
+          </a:prstGeom>
+          <a:noFill/>
+          <a:ln/>
+        </p:spPr>
+        <p:txBody>
+          <a:bodyPr wrap="square" rtlCol="0"/>
+          <a:lstStyle/>
+          <a:p>
+            <a:pPr algn="l" indent="0" marL="0">
+              <a:lnSpc>
+                <a:spcPts val="2500"/>
+              </a:lnSpc>
+              <a:buNone/>
+            </a:pPr>
+            <a:r>
+              <a:rPr lang="en-US" sz="1500" b="1" dirty="0">
+                <a:solidFill>
+                  <a:srgbClr val="FBF9F4"/>
+                </a:solidFill>
+              </a:rPr>
+              <a:t>A horror antagonist that models the individual player, and a measurement that says how well.</a:t>
+            </a:r>
+            <a:endParaRPr lang="en-US" sz="1500" dirty="0"/>
+          </a:p>
+          <a:p>
+            <a:pPr algn="l" indent="0" marL="0">
+              <a:lnSpc>
+                <a:spcPts val="2500"/>
+              </a:lnSpc>
+              <a:buNone/>
+            </a:pPr>
+            <a:endParaRPr lang="en-US" sz="1500" dirty="0"/>
+          </a:p>
+          <a:p>
+            <a:pPr algn="l" indent="0" marL="0">
+              <a:lnSpc>
+                <a:spcPts val="2500"/>
+              </a:lnSpc>
+              <a:buNone/>
+            </a:pPr>
+            <a:r>
+              <a:rPr lang="en-US" sz="1500" dirty="0">
+                <a:solidFill>
+                  <a:srgbClr val="FBF9F4"/>
+                </a:solidFill>
+              </a:rPr>
+              <a:t>It predicts the next room 83.6% of the time against a habitual player, and 26.7% against one with no habits — which is exactly what having no model scores. The gain is learned behaviour, not leakage. Against an oracle that can see the player's internal state, it reaches 97% of the achievable signal from behaviour alone.</a:t>
+            </a:r>
+            <a:endParaRPr lang="en-US" sz="1500" dirty="0"/>
+          </a:p>
+          <a:p>
+            <a:pPr algn="l" indent="0" marL="0">
+              <a:lnSpc>
+                <a:spcPts val="2500"/>
+              </a:lnSpc>
+              <a:buNone/>
+            </a:pPr>
+            <a:endParaRPr lang="en-US" sz="1500" dirty="0"/>
+          </a:p>
+          <a:p>
+            <a:pPr algn="l" indent="0" marL="0">
+              <a:lnSpc>
+                <a:spcPts val="2500"/>
+              </a:lnSpc>
+              <a:buNone/>
+            </a:pPr>
+            <a:r>
+              <a:rPr lang="en-US" sz="1500" b="1" dirty="0">
+                <a:solidFill>
+                  <a:srgbClr val="FFB545"/>
+                </a:solidFill>
+              </a:rPr>
+              <a:t>It gets better at catching a returning player, and we now know the one condition where it does not.</a:t>
+            </a:r>
+            <a:endParaRPr lang="en-US" sz="1500" dirty="0"/>
+          </a:p>
+          <a:p>
+            <a:pPr algn="l" indent="0" marL="0">
+              <a:lnSpc>
+                <a:spcPts val="2500"/>
+              </a:lnSpc>
+              <a:buNone/>
+            </a:pPr>
+            <a:endParaRPr lang="en-US" sz="1500" dirty="0"/>
+          </a:p>
+          <a:p>
+            <a:pPr algn="l" indent="0" marL="0">
+              <a:lnSpc>
+                <a:spcPts val="2500"/>
+              </a:lnSpc>
+              <a:buNone/>
+            </a:pPr>
+            <a:r>
+              <a:rPr lang="en-US" sz="1500" dirty="0">
+                <a:solidFill>
+                  <a:srgbClr val="7A7059"/>
+                </a:solidFill>
+              </a:rPr>
+              <a:t>Next: human playtest traces in place of scripted players, and a predictor re-keyed on features that survive a rewired building.</a:t>
+            </a:r>
+            <a:endParaRPr lang="en-US" sz="1500" dirty="0"/>
+          </a:p>
+        </p:txBody>
+      </p:sp>
+      <p:sp>
+        <p:nvSpPr>
+          <p:cNvPr id="4" name="Text 2"/>
+          <p:cNvSpPr txBox="1"/>
+          <p:nvPr/>
+        </p:nvSpPr>
+        <p:spPr>
+          <a:xfrm>
+            <a:off x="868680" y="6236208"/>
+            <a:ext cx="6400800" cy="320040"/>
+          </a:xfrm>
+          <a:prstGeom prst="rect">
+            <a:avLst/>
+          </a:prstGeom>
+          <a:noFill/>
+          <a:ln/>
+        </p:spPr>
+        <p:txBody>
+          <a:bodyPr wrap="square" lIns="0" tIns="0" rIns="0" bIns="0" rtlCol="0" anchor="ctr"/>
+          <a:lstStyle/>
+          <a:p>
+            <a:pPr indent="0" marL="0">
+              <a:buNone/>
+            </a:pPr>
+            <a:r>
+              <a:rPr lang="en-US" sz="1250" dirty="0">
+                <a:solidFill>
+                  <a:srgbClr val="7A7059"/>
+                </a:solidFill>
+                <a:latin typeface="Courier New" pitchFamily="34" charset="0"/>
+                <a:ea typeface="Courier New" pitchFamily="34" charset="-122"/>
+                <a:cs typeface="Courier New" pitchFamily="34" charset="-120"/>
+              </a:rPr>
+              <a:t>github.com/Sh1v4mKum4r/parity</a:t>
+            </a:r>
+            <a:endParaRPr lang="en-US" sz="1250" dirty="0"/>
           </a:p>
         </p:txBody>
       </p:sp>

</xml_diff>